<commit_message>
Fix invisible logo on white-background slides
The corner watermark and title-slide logo used a single asset (white
tiger head on the mark) that's only visible against a dark background —
on white content slides the head disappeared entirely.

The mark now ships in two recolored variants: team5010-logo-onnavy.png
(white head, for the navy title slide and the two navy content slides
per deck) and team5010-logo-onwhite.png (black head, for every white
slide). addFooter's new `dark` flag picks the right one and also swaps
the footer text to a lighter tone so it stays legible on navy — the
previous muted gray was low-contrast there too.

Rebuilt and re-validated all three decks; confirmed via the packaged
media that each deck embeds exactly one navy-variant image per navy
slide (title + 2) and the white variant everywhere else.
</commit_message>
<xml_diff>
--- a/docs/presentations/v3/00-orientation.pptx
+++ b/docs/presentations/v3/00-orientation.pptx
@@ -1767,7 +1767,7 @@
       </p:grpSpPr>
       <p:pic>
         <p:nvPicPr>
-          <p:cNvPr id="2" name="Image 0" descr="/home/user/BasicRobotLessons/docs/presentations/v3/template/assets/logo/team5010-logo.png">    </p:cNvPr>
+          <p:cNvPr id="2" name="Image 0" descr="/home/user/BasicRobotLessons/docs/presentations/v3/template/assets/logo/team5010-logo-onnavy.png">    </p:cNvPr>
           <p:cNvPicPr>
             <a:picLocks noChangeAspect="1"/>
           </p:cNvPicPr>
@@ -2537,7 +2537,7 @@
             <a:r>
               <a:rPr lang="en-US" sz="2000" spc="100" kern="0" dirty="0">
                 <a:solidFill>
-                  <a:srgbClr val="5B6B84"/>
+                  <a:srgbClr val="7A93B8"/>
                 </a:solidFill>
                 <a:latin typeface="Calibri" pitchFamily="34" charset="0"/>
                 <a:ea typeface="Calibri" pitchFamily="34" charset="-122"/>
@@ -2576,7 +2576,7 @@
             <a:r>
               <a:rPr lang="en-US" sz="2000" dirty="0">
                 <a:solidFill>
-                  <a:srgbClr val="5B6B84"/>
+                  <a:srgbClr val="7A93B8"/>
                 </a:solidFill>
                 <a:latin typeface="Calibri" pitchFamily="34" charset="0"/>
                 <a:ea typeface="Calibri" pitchFamily="34" charset="-122"/>
@@ -2590,7 +2590,7 @@
       </p:sp>
       <p:pic>
         <p:nvPicPr>
-          <p:cNvPr id="19" name="Image 1" descr="/home/user/BasicRobotLessons/docs/presentations/v3/template/assets/logo/team5010-logo.png">    </p:cNvPr>
+          <p:cNvPr id="19" name="Image 1" descr="/home/user/BasicRobotLessons/docs/presentations/v3/template/assets/logo/team5010-logo-onnavy.png">    </p:cNvPr>
           <p:cNvPicPr>
             <a:picLocks noChangeAspect="1"/>
           </p:cNvPicPr>
@@ -3207,7 +3207,7 @@
       </p:sp>
       <p:pic>
         <p:nvPicPr>
-          <p:cNvPr id="17" name="Image 2" descr="/home/user/BasicRobotLessons/docs/presentations/v3/template/assets/logo/team5010-logo.png">    </p:cNvPr>
+          <p:cNvPr id="17" name="Image 2" descr="/home/user/BasicRobotLessons/docs/presentations/v3/template/assets/logo/team5010-logo-onwhite.png">    </p:cNvPr>
           <p:cNvPicPr>
             <a:picLocks noChangeAspect="1"/>
           </p:cNvPicPr>
@@ -3881,7 +3881,7 @@
       </p:sp>
       <p:pic>
         <p:nvPicPr>
-          <p:cNvPr id="18" name="Image 3" descr="/home/user/BasicRobotLessons/docs/presentations/v3/template/assets/logo/team5010-logo.png">    </p:cNvPr>
+          <p:cNvPr id="18" name="Image 3" descr="/home/user/BasicRobotLessons/docs/presentations/v3/template/assets/logo/team5010-logo-onwhite.png">    </p:cNvPr>
           <p:cNvPicPr>
             <a:picLocks noChangeAspect="1"/>
           </p:cNvPicPr>
@@ -4687,7 +4687,7 @@
       </p:sp>
       <p:pic>
         <p:nvPicPr>
-          <p:cNvPr id="25" name="Image 5" descr="/home/user/BasicRobotLessons/docs/presentations/v3/template/assets/logo/team5010-logo.png">    </p:cNvPr>
+          <p:cNvPr id="25" name="Image 5" descr="/home/user/BasicRobotLessons/docs/presentations/v3/template/assets/logo/team5010-logo-onwhite.png">    </p:cNvPr>
           <p:cNvPicPr>
             <a:picLocks noChangeAspect="1"/>
           </p:cNvPicPr>
@@ -5261,7 +5261,7 @@
       </p:sp>
       <p:pic>
         <p:nvPicPr>
-          <p:cNvPr id="18" name="Image 1" descr="/home/user/BasicRobotLessons/docs/presentations/v3/template/assets/logo/team5010-logo.png">    </p:cNvPr>
+          <p:cNvPr id="18" name="Image 1" descr="/home/user/BasicRobotLessons/docs/presentations/v3/template/assets/logo/team5010-logo-onwhite.png">    </p:cNvPr>
           <p:cNvPicPr>
             <a:picLocks noChangeAspect="1"/>
           </p:cNvPicPr>
@@ -5942,7 +5942,7 @@
       </p:sp>
       <p:pic>
         <p:nvPicPr>
-          <p:cNvPr id="17" name="Image 1" descr="/home/user/BasicRobotLessons/docs/presentations/v3/template/assets/logo/team5010-logo.png">    </p:cNvPr>
+          <p:cNvPr id="17" name="Image 1" descr="/home/user/BasicRobotLessons/docs/presentations/v3/template/assets/logo/team5010-logo-onwhite.png">    </p:cNvPr>
           <p:cNvPicPr>
             <a:picLocks noChangeAspect="1"/>
           </p:cNvPicPr>
@@ -6580,7 +6580,7 @@
       </p:sp>
       <p:pic>
         <p:nvPicPr>
-          <p:cNvPr id="19" name="Image 2" descr="/home/user/BasicRobotLessons/docs/presentations/v3/template/assets/logo/team5010-logo.png">    </p:cNvPr>
+          <p:cNvPr id="19" name="Image 2" descr="/home/user/BasicRobotLessons/docs/presentations/v3/template/assets/logo/team5010-logo-onwhite.png">    </p:cNvPr>
           <p:cNvPicPr>
             <a:picLocks noChangeAspect="1"/>
           </p:cNvPicPr>
@@ -7031,7 +7031,7 @@
             <a:r>
               <a:rPr lang="en-US" sz="2000" spc="100" kern="0" dirty="0">
                 <a:solidFill>
-                  <a:srgbClr val="5B6B84"/>
+                  <a:srgbClr val="7A93B8"/>
                 </a:solidFill>
                 <a:latin typeface="Calibri" pitchFamily="34" charset="0"/>
                 <a:ea typeface="Calibri" pitchFamily="34" charset="-122"/>
@@ -7070,7 +7070,7 @@
             <a:r>
               <a:rPr lang="en-US" sz="2000" dirty="0">
                 <a:solidFill>
-                  <a:srgbClr val="5B6B84"/>
+                  <a:srgbClr val="7A93B8"/>
                 </a:solidFill>
                 <a:latin typeface="Calibri" pitchFamily="34" charset="0"/>
                 <a:ea typeface="Calibri" pitchFamily="34" charset="-122"/>
@@ -7084,7 +7084,7 @@
       </p:sp>
       <p:pic>
         <p:nvPicPr>
-          <p:cNvPr id="15" name="Image 1" descr="/home/user/BasicRobotLessons/docs/presentations/v3/template/assets/logo/team5010-logo.png">    </p:cNvPr>
+          <p:cNvPr id="15" name="Image 1" descr="/home/user/BasicRobotLessons/docs/presentations/v3/template/assets/logo/team5010-logo-onnavy.png">    </p:cNvPr>
           <p:cNvPicPr>
             <a:picLocks noChangeAspect="1"/>
           </p:cNvPicPr>
@@ -8040,7 +8040,7 @@
       </p:sp>
       <p:pic>
         <p:nvPicPr>
-          <p:cNvPr id="28" name="Image 1" descr="/home/user/BasicRobotLessons/docs/presentations/v3/template/assets/logo/team5010-logo.png">    </p:cNvPr>
+          <p:cNvPr id="28" name="Image 1" descr="/home/user/BasicRobotLessons/docs/presentations/v3/template/assets/logo/team5010-logo-onwhite.png">    </p:cNvPr>
           <p:cNvPicPr>
             <a:picLocks noChangeAspect="1"/>
           </p:cNvPicPr>
@@ -8873,7 +8873,7 @@
       </p:sp>
       <p:pic>
         <p:nvPicPr>
-          <p:cNvPr id="22" name="Image 1" descr="/home/user/BasicRobotLessons/docs/presentations/v3/template/assets/logo/team5010-logo.png">    </p:cNvPr>
+          <p:cNvPr id="22" name="Image 1" descr="/home/user/BasicRobotLessons/docs/presentations/v3/template/assets/logo/team5010-logo-onwhite.png">    </p:cNvPr>
           <p:cNvPicPr>
             <a:picLocks noChangeAspect="1"/>
           </p:cNvPicPr>

</xml_diff>

<commit_message>
Add presenter notes to Lessons 0, 2-10 decks
Applies the presenter-notes convention piloted on Lesson 1 to the rest
of the numbered v3 lesson decks: every slide (including the title
slide) gets an addNotes() call sourced from the corresponding lesson's
markdown, carrying material that was cut for space and isn't already
visible on the slide (blockquote callouts, "why" asides, worked
examples, measured results).

Rebuilt each .pptx, ran audit-overflow.js after each deck (no new
findings beyond the pre-existing margin-only ones), and validated with
validate.py.
</commit_message>
<xml_diff>
--- a/docs/presentations/v3/00-orientation.pptx
+++ b/docs/presentations/v3/00-orientation.pptx
@@ -512,7 +512,7 @@
           <a:p>
             <a:r>
               <a:rPr lang="en-US" dirty="0"/>
-              <a:t/>
+              <a:t>The very first lesson — before this, students have a template project that builds but does nothing recognizable yet. Frame the whole lesson as three moves: understand the boot sequence, run it once with nothing changed, then make one real edit and watch the robot respond.</a:t>
             </a:r>
             <a:endParaRPr lang="en-US" dirty="0"/>
           </a:p>
@@ -600,7 +600,7 @@
           <a:p>
             <a:r>
               <a:rPr lang="en-US" dirty="0"/>
-              <a:t/>
+              <a:t>Don't let these get skipped — most of the actual learning happens when a student has to think, not when copying code out of the walkthrough. First, MyAuto.java doesn't have a start() method yet — add one matching MyTeleop's shape, print a different message, and confirm it only shows up when My Auto is picked, not My Teleop. Second, break it on purpose: delete a semicolon, run ./gradlew build, and read the error carefully — note the file and line number it names. Reading compiler errors is a real skill, and the sooner students are comfortable with them the better. Put the semicolon back when done.</a:t>
             </a:r>
             <a:endParaRPr lang="en-US" dirty="0"/>
           </a:p>
@@ -688,7 +688,7 @@
           <a:p>
             <a:r>
               <a:rPr lang="en-US" dirty="0"/>
-              <a:t/>
+              <a:t>A robot program here is a stack of classes in packages, same as always — but now some of those classes are opmodes, tagged with an annotation like @Teleop so the framework can find them and offer them by name on the Driver Station. Whichever opmode gets picked is the one whose periodic() starts ticking about 50 times a second — that's still the heartbeat everything else in this course hangs off, just with one more layer: which piece of code the heartbeat is driving is now a choice made at runtime, not baked into a single class. That's plenty for one sitting.</a:t>
             </a:r>
             <a:endParaRPr lang="en-US" dirty="0"/>
           </a:p>
@@ -776,7 +776,7 @@
           <a:p>
             <a:r>
               <a:rPr lang="en-US" dirty="0"/>
-              <a:t/>
+              <a:t>Get the template building in simulation, see how the pieces fit together, and make the first code change — printing a message the moment teleop wakes up. Half of what's on screen (Main.java, the annotation machinery) won't matter for a while, and that's fine to say out loud — the goal today is the picture, not full understanding of every file.</a:t>
             </a:r>
             <a:endParaRPr lang="en-US" dirty="0"/>
           </a:p>
@@ -864,7 +864,7 @@
           <a:p>
             <a:r>
               <a:rPr lang="en-US" dirty="0"/>
-              <a:t/>
+              <a:t>That's totally normal to find unfamiliar — half of it won't matter for a while. Read the comments once, let the picture settle (boot, then hand off to whichever opmode is picked), and keep going. Robot.java boots the framework and students will rarely touch it; MyTeleop.java and MyAuto.java are what the robot does when driven vs. left to run itself in autonomous.</a:t>
             </a:r>
             <a:endParaRPr lang="en-US" dirty="0"/>
           </a:p>
@@ -952,7 +952,7 @@
           <a:p>
             <a:r>
               <a:rPr lang="en-US" dirty="0"/>
-              <a:t/>
+              <a:t>That's a package declaration. Packages keep class names from colliding across libraries — if two vendors both shipped a Timer class, packages are how you'd tell them apart. Here the packages just mirror the folder structure: first.robot is the folder first/robot, opmodes live in first.robot.opmode. Below the package line, every file defines a class — a blueprint. Robot is the class the whole program boots from; MyTeleop and MyAuto are opmodes, and every mechanism or command written from Lesson 1 on gets its own class too.</a:t>
             </a:r>
             <a:endParaRPr lang="en-US" dirty="0"/>
           </a:p>
@@ -1040,7 +1040,7 @@
           <a:p>
             <a:r>
               <a:rPr lang="en-US" dirty="0"/>
-              <a:t/>
+              <a:t>Inside a class, the code that actually runs lives in methods — named blocks of code that do something. Five methods, all currently empty, each named after the moment it fires. The one to focus on today is periodic() — the others get met as they're needed. Like every method WPILib calls, you don't call periodic() yourself; the framework does, on its own schedule. @Override next to it means what it always will in this course: "yes, I know this method already has a meaning; I'm supplying my own."</a:t>
             </a:r>
             <a:endParaRPr lang="en-US" dirty="0"/>
           </a:p>
@@ -1128,7 +1128,7 @@
           <a:p>
             <a:r>
               <a:rPr lang="en-US" dirty="0"/>
-              <a:t/>
+              <a:t>@Teleop sitting above the whole class is a different kind of thing: an annotation — a tag that tells the framework something about the class underneath it, without being a method or a field itself. It says "this is a piece of robot behavior a human can pick on the Driver Station, and call it My Teleop unless told otherwise." MyAuto.java has the same idea with @Autonomous instead. Neither annotation runs any code by itself — it's a label the framework reads before the code ever executes. This is the biggest mental shift in the lesson, worth saying plainly: you don't write one robot program that runs top to bottom. You write several small ones — opmodes — and something else decides which one is running right now.</a:t>
             </a:r>
             <a:endParaRPr lang="en-US" dirty="0"/>
           </a:p>
@@ -1216,7 +1216,7 @@
           <a:p>
             <a:r>
               <a:rPr lang="en-US" dirty="0"/>
-              <a:t/>
+              <a:t>An opmode is a named, selectable chunk of robot behavior. MyTeleop and MyAuto are both opmodes, and a human picks one by name on the Driver Station before anything in it runs. Once picked and enabled, its periodic() method runs about 50 times a second, forever, until something else is picked or the robot disables. Each run is a tick — the heartbeat, same idea as always: a fast loop, ticking away, doing a little work each time. You never write while (true) yourself; the framework is the loop, and you plug things into it. If students take one thing from this lesson, it's this picture, with one layer added: which piece of code the framework is ticking depends on what's selected.</a:t>
             </a:r>
             <a:endParaRPr lang="en-US" dirty="0"/>
           </a:p>
@@ -1304,7 +1304,7 @@
           <a:p>
             <a:r>
               <a:rPr lang="en-US" dirty="0"/>
-              <a:t/>
+              <a:t>Either click the WPILib icon in VS Code's left sidebar (or Ctrl+Shift+P → WPILib: Simulate Robot Code), or run ./gradlew simulateJava from the project folder in PowerShell. The very first run downloads a pile of dependencies and can take several minutes — grab a drink, this is normal, not broken. When the build finishes, VS Code asks about Sim GUI vs. Real Driverstation — Sim GUI is correct for now. Nothing moves once enabled, because there's no motor yet — that's Lesson 1, worth saying so nobody thinks something's broken.</a:t>
             </a:r>
             <a:endParaRPr lang="en-US" dirty="0"/>
           </a:p>
@@ -1392,7 +1392,7 @@
           <a:p>
             <a:r>
               <a:rPr lang="en-US" dirty="0"/>
-              <a:t/>
+              <a:t>start() runs exactly once — the instant the opmode goes from disabled to enabled. That makes it a better home for a one-time message than periodic(), which would print the same line fifty times a second and flood the terminal. Three things worth naming in this one line: System.out.println(...) is a method call — asking a method to run and handing it something in the parentheses. The stuff in double quotes is a String, Java's word for a chunk of literal text. And the whole line ends in a semicolon — every statement in Java does, and forgetting it is the number-one beginner compile error, better met now than later. Run the simulator again, pick My Teleop, flip to Enabled, and the message should be sitting right there in the terminal — the robot just changed what it does.</a:t>
             </a:r>
             <a:endParaRPr lang="en-US" dirty="0"/>
           </a:p>

</xml_diff>